<commit_message>
Polish report and presentation wording
</commit_message>
<xml_diff>
--- a/energy_demand_forecast_presentation.pptx
+++ b/energy_demand_forecast_presentation.pptx
@@ -8052,7 +8052,7 @@
               </a:defRPr>
             </a:pPr>
             <a:r>
-              <a:t>고전 시계열 baseline</a:t>
+              <a:t>고전 시계열 베이스라인</a:t>
             </a:r>
           </a:p>
         </p:txBody>
@@ -10057,7 +10057,7 @@
               </a:defRPr>
             </a:pPr>
             <a:r>
-              <a:t>예측구간과 불확실성</a:t>
+              <a:t>예측 구간과 불확실성</a:t>
             </a:r>
           </a:p>
         </p:txBody>

</xml_diff>